<commit_message>
Revamp system precheck analysis - link budget and rf budget
</commit_message>
<xml_diff>
--- a/SystemPrechecks/Artifacts/Decks/SystemPrecheck_TechnicalStory.pptx
+++ b/SystemPrechecks/Artifacts/Decks/SystemPrecheck_TechnicalStory.pptx
@@ -13,6 +13,17 @@
     <p:sldId id="261" r:id="rId11"/>
     <p:sldId id="262" r:id="rId12"/>
     <p:sldId id="263" r:id="rId13"/>
+    <p:sldId id="264" r:id="rId14"/>
+    <p:sldId id="265" r:id="rId15"/>
+    <p:sldId id="266" r:id="rId16"/>
+    <p:sldId id="267" r:id="rId17"/>
+    <p:sldId id="268" r:id="rId18"/>
+    <p:sldId id="269" r:id="rId19"/>
+    <p:sldId id="270" r:id="rId20"/>
+    <p:sldId id="271" r:id="rId21"/>
+    <p:sldId id="272" r:id="rId22"/>
+    <p:sldId id="273" r:id="rId23"/>
+    <p:sldId id="274" r:id="rId24"/>
   </p:sldIdLst>
   <p:sldSz cx="12192000" cy="6858000"/>
   <p:notesSz cx="6858000" cy="9144000"/>
@@ -3276,7 +3287,7 @@
           <a:lstStyle/>
           <a:p>
             <a:r>
-              <a:t>Generated from MATLAB assets on 2026-07-17 15:09</a:t>
+              <a:t>Generated from MATLAB assets on 2026-07-30 11:26</a:t>
             </a:r>
           </a:p>
         </p:txBody>
@@ -3350,6 +3361,1430 @@
     <p:extLst>
       <p:ext uri="{BB962C8B-B14F-4D97-AF65-F5344CB8AC3E}">
         <p14:creationId xmlns:p14="http://schemas.microsoft.com/office/powerpoint/2010/main" val="2532984289"/>
+      </p:ext>
+    </p:extLst>
+  </p:cSld>
+</p:sld>
+</file>
+
+<file path=ppt/slides/slide10.xml><?xml version="1.0" encoding="utf-8"?>
+<p:sld xmlns:a="http://schemas.openxmlformats.org/drawingml/2006/main" xmlns:p="http://schemas.openxmlformats.org/presentationml/2006/main" xmlns:r="http://schemas.openxmlformats.org/officeDocument/2006/relationships">
+  <p:cSld name="">
+    <p:spTree>
+      <p:nvGrpSpPr>
+        <p:cNvPr id="1" name=""/>
+        <p:cNvGrpSpPr/>
+        <p:nvPr/>
+      </p:nvGrpSpPr>
+      <p:grpSpPr>
+        <a:xfrm>
+          <a:off x="0" y="0"/>
+          <a:ext cx="0" cy="0"/>
+          <a:chOff x="0" y="0"/>
+          <a:chExt cx="0" cy="0"/>
+        </a:xfrm>
+      </p:grpSpPr>
+      <p:sp>
+        <p:nvSpPr>
+          <p:cNvPr id="2" name="Title"/>
+          <p:cNvSpPr>
+            <a:spLocks noGrp="1"/>
+          </p:cNvSpPr>
+          <p:nvPr>
+            <p:ph type="title"/>
+          </p:nvPr>
+        </p:nvSpPr>
+        <p:spPr/>
+        <p:txBody>
+          <a:bodyPr/>
+          <a:lstStyle/>
+          <a:p>
+            <a:r>
+              <a:t>Recovered-ROI Baseline Combined Max-SNR Coverage</a:t>
+            </a:r>
+          </a:p>
+        </p:txBody>
+      </p:sp>
+      <p:pic>
+        <p:nvPicPr>
+          <p:cNvPr id="3" name="Content"/>
+          <p:cNvPicPr>
+            <a:picLocks noChangeAspect="1" noGrp="1"/>
+          </p:cNvPicPr>
+          <p:nvPr>
+            <p:ph idx="1"/>
+          </p:nvPr>
+        </p:nvPicPr>
+        <p:blipFill>
+          <a:blip r:embed="rId2">
+            <a:extLst>
+              <a:ext uri="{28A0092B-C50C-407E-A947-70E740481C1C}">
+                <a14:useLocalDpi xmlns:a14="http://schemas.microsoft.com/office/drawing/2010/main" val="0"/>
+              </a:ext>
+            </a:extLst>
+          </a:blip>
+          <a:stretch>
+            <a:fillRect/>
+          </a:stretch>
+        </p:blipFill>
+        <p:spPr>
+          <a:xfrm>
+            <a:off x="2359851" y="1825625"/>
+            <a:ext cx="7472297" cy="4351338"/>
+          </a:xfrm>
+          <a:prstGeom prst="rect"/>
+        </p:spPr>
+      </p:pic>
+      <p:sp>
+        <p:nvSpPr>
+          <p:cNvPr id="4" name="Date"/>
+          <p:cNvSpPr>
+            <a:spLocks noGrp="1"/>
+          </p:cNvSpPr>
+          <p:nvPr>
+            <p:ph idx="10" sz="half" type="dt"/>
+          </p:nvPr>
+        </p:nvSpPr>
+        <p:spPr/>
+        <p:txBody>
+          <a:bodyPr/>
+          <a:lstStyle/>
+          <a:p>
+            <a:fld id="{5C2C3F0B-2B7F-4782-B315-33E516447C25}" type="datetimeFigureOut">
+              <a:rPr lang="en-US" smtClean="0"/>
+              <a:t>3/21/2019</a:t>
+            </a:fld>
+            <a:endParaRPr lang="en-US"/>
+          </a:p>
+        </p:txBody>
+      </p:sp>
+      <p:sp>
+        <p:nvSpPr>
+          <p:cNvPr id="5" name="Footer"/>
+          <p:cNvSpPr>
+            <a:spLocks noGrp="1"/>
+          </p:cNvSpPr>
+          <p:nvPr>
+            <p:ph idx="11" sz="quarter" type="ftr"/>
+          </p:nvPr>
+        </p:nvSpPr>
+        <p:spPr/>
+        <p:txBody>
+          <a:bodyPr/>
+          <a:lstStyle/>
+          <a:p>
+            <a:endParaRPr lang="en-US"/>
+          </a:p>
+        </p:txBody>
+      </p:sp>
+      <p:sp>
+        <p:nvSpPr>
+          <p:cNvPr id="6" name="Slide Number"/>
+          <p:cNvSpPr>
+            <a:spLocks noGrp="1"/>
+          </p:cNvSpPr>
+          <p:nvPr>
+            <p:ph idx="12" sz="quarter" type="sldNum"/>
+          </p:nvPr>
+        </p:nvSpPr>
+        <p:spPr/>
+        <p:txBody>
+          <a:bodyPr/>
+          <a:lstStyle/>
+          <a:p>
+            <a:fld id="{6FACB95C-998B-4B89-BDB5-3B69D78FCBB4}" type="slidenum">
+              <a:rPr lang="en-US" smtClean="0"/>
+              <a:t>‹#›</a:t>
+            </a:fld>
+            <a:endParaRPr lang="en-US"/>
+          </a:p>
+        </p:txBody>
+      </p:sp>
+    </p:spTree>
+    <p:extLst>
+      <p:ext uri="{BB962C8B-B14F-4D97-AF65-F5344CB8AC3E}">
+        <p14:creationId xmlns:p14="http://schemas.microsoft.com/office/powerpoint/2010/main" val="1534215338"/>
+      </p:ext>
+    </p:extLst>
+  </p:cSld>
+</p:sld>
+</file>
+
+<file path=ppt/slides/slide11.xml><?xml version="1.0" encoding="utf-8"?>
+<p:sld xmlns:a="http://schemas.openxmlformats.org/drawingml/2006/main" xmlns:p="http://schemas.openxmlformats.org/presentationml/2006/main" xmlns:r="http://schemas.openxmlformats.org/officeDocument/2006/relationships">
+  <p:cSld name="">
+    <p:spTree>
+      <p:nvGrpSpPr>
+        <p:cNvPr id="1" name=""/>
+        <p:cNvGrpSpPr/>
+        <p:nvPr/>
+      </p:nvGrpSpPr>
+      <p:grpSpPr>
+        <a:xfrm>
+          <a:off x="0" y="0"/>
+          <a:ext cx="0" cy="0"/>
+          <a:chOff x="0" y="0"/>
+          <a:chExt cx="0" cy="0"/>
+        </a:xfrm>
+      </p:grpSpPr>
+      <p:sp>
+        <p:nvSpPr>
+          <p:cNvPr id="2" name="Title"/>
+          <p:cNvSpPr>
+            <a:spLocks noGrp="1"/>
+          </p:cNvSpPr>
+          <p:nvPr>
+            <p:ph type="title"/>
+          </p:nvPr>
+        </p:nvSpPr>
+        <p:spPr/>
+        <p:txBody>
+          <a:bodyPr/>
+          <a:lstStyle/>
+          <a:p>
+            <a:r>
+              <a:t>Recovered-ROI Baseline Regional SNR View</a:t>
+            </a:r>
+          </a:p>
+        </p:txBody>
+      </p:sp>
+      <p:pic>
+        <p:nvPicPr>
+          <p:cNvPr id="3" name="Content"/>
+          <p:cNvPicPr>
+            <a:picLocks noChangeAspect="1" noGrp="1"/>
+          </p:cNvPicPr>
+          <p:nvPr>
+            <p:ph idx="1"/>
+          </p:nvPr>
+        </p:nvPicPr>
+        <p:blipFill>
+          <a:blip r:embed="rId2">
+            <a:extLst>
+              <a:ext uri="{28A0092B-C50C-407E-A947-70E740481C1C}">
+                <a14:useLocalDpi xmlns:a14="http://schemas.microsoft.com/office/drawing/2010/main" val="0"/>
+              </a:ext>
+            </a:extLst>
+          </a:blip>
+          <a:stretch>
+            <a:fillRect/>
+          </a:stretch>
+        </p:blipFill>
+        <p:spPr>
+          <a:xfrm>
+            <a:off x="2146115" y="1825625"/>
+            <a:ext cx="7899769" cy="4351338"/>
+          </a:xfrm>
+          <a:prstGeom prst="rect"/>
+        </p:spPr>
+      </p:pic>
+      <p:sp>
+        <p:nvSpPr>
+          <p:cNvPr id="4" name="Date"/>
+          <p:cNvSpPr>
+            <a:spLocks noGrp="1"/>
+          </p:cNvSpPr>
+          <p:nvPr>
+            <p:ph idx="10" sz="half" type="dt"/>
+          </p:nvPr>
+        </p:nvSpPr>
+        <p:spPr/>
+        <p:txBody>
+          <a:bodyPr/>
+          <a:lstStyle/>
+          <a:p>
+            <a:fld id="{5C2C3F0B-2B7F-4782-B315-33E516447C25}" type="datetimeFigureOut">
+              <a:rPr lang="en-US" smtClean="0"/>
+              <a:t>3/21/2019</a:t>
+            </a:fld>
+            <a:endParaRPr lang="en-US"/>
+          </a:p>
+        </p:txBody>
+      </p:sp>
+      <p:sp>
+        <p:nvSpPr>
+          <p:cNvPr id="5" name="Footer"/>
+          <p:cNvSpPr>
+            <a:spLocks noGrp="1"/>
+          </p:cNvSpPr>
+          <p:nvPr>
+            <p:ph idx="11" sz="quarter" type="ftr"/>
+          </p:nvPr>
+        </p:nvSpPr>
+        <p:spPr/>
+        <p:txBody>
+          <a:bodyPr/>
+          <a:lstStyle/>
+          <a:p>
+            <a:endParaRPr lang="en-US"/>
+          </a:p>
+        </p:txBody>
+      </p:sp>
+      <p:sp>
+        <p:nvSpPr>
+          <p:cNvPr id="6" name="Slide Number"/>
+          <p:cNvSpPr>
+            <a:spLocks noGrp="1"/>
+          </p:cNvSpPr>
+          <p:nvPr>
+            <p:ph idx="12" sz="quarter" type="sldNum"/>
+          </p:nvPr>
+        </p:nvSpPr>
+        <p:spPr/>
+        <p:txBody>
+          <a:bodyPr/>
+          <a:lstStyle/>
+          <a:p>
+            <a:fld id="{6FACB95C-998B-4B89-BDB5-3B69D78FCBB4}" type="slidenum">
+              <a:rPr lang="en-US" smtClean="0"/>
+              <a:t>‹#›</a:t>
+            </a:fld>
+            <a:endParaRPr lang="en-US"/>
+          </a:p>
+        </p:txBody>
+      </p:sp>
+    </p:spTree>
+    <p:extLst>
+      <p:ext uri="{BB962C8B-B14F-4D97-AF65-F5344CB8AC3E}">
+        <p14:creationId xmlns:p14="http://schemas.microsoft.com/office/powerpoint/2010/main" val="1534215338"/>
+      </p:ext>
+    </p:extLst>
+  </p:cSld>
+</p:sld>
+</file>
+
+<file path=ppt/slides/slide12.xml><?xml version="1.0" encoding="utf-8"?>
+<p:sld xmlns:a="http://schemas.openxmlformats.org/drawingml/2006/main" xmlns:p="http://schemas.openxmlformats.org/presentationml/2006/main" xmlns:r="http://schemas.openxmlformats.org/officeDocument/2006/relationships">
+  <p:cSld name="">
+    <p:spTree>
+      <p:nvGrpSpPr>
+        <p:cNvPr id="1" name=""/>
+        <p:cNvGrpSpPr/>
+        <p:nvPr/>
+      </p:nvGrpSpPr>
+      <p:grpSpPr>
+        <a:xfrm>
+          <a:off x="0" y="0"/>
+          <a:ext cx="0" cy="0"/>
+          <a:chOff x="0" y="0"/>
+          <a:chExt cx="0" cy="0"/>
+        </a:xfrm>
+      </p:grpSpPr>
+      <p:sp>
+        <p:nvSpPr>
+          <p:cNvPr id="2" name="Title"/>
+          <p:cNvSpPr>
+            <a:spLocks noGrp="1"/>
+          </p:cNvSpPr>
+          <p:nvPr>
+            <p:ph type="title"/>
+          </p:nvPr>
+        </p:nvSpPr>
+        <p:spPr/>
+        <p:txBody>
+          <a:bodyPr/>
+          <a:lstStyle/>
+          <a:p>
+            <a:r>
+              <a:t>Recovered-ROI Baseline Detectability Summary</a:t>
+            </a:r>
+          </a:p>
+        </p:txBody>
+      </p:sp>
+      <p:pic>
+        <p:nvPicPr>
+          <p:cNvPr id="3" name="Content"/>
+          <p:cNvPicPr>
+            <a:picLocks noChangeAspect="1" noGrp="1"/>
+          </p:cNvPicPr>
+          <p:nvPr>
+            <p:ph idx="1"/>
+          </p:nvPr>
+        </p:nvPicPr>
+        <p:blipFill>
+          <a:blip r:embed="rId2">
+            <a:extLst>
+              <a:ext uri="{28A0092B-C50C-407E-A947-70E740481C1C}">
+                <a14:useLocalDpi xmlns:a14="http://schemas.microsoft.com/office/drawing/2010/main" val="0"/>
+              </a:ext>
+            </a:extLst>
+          </a:blip>
+          <a:stretch>
+            <a:fillRect/>
+          </a:stretch>
+        </p:blipFill>
+        <p:spPr>
+          <a:xfrm>
+            <a:off x="2393808" y="1825625"/>
+            <a:ext cx="7404382" cy="4351338"/>
+          </a:xfrm>
+          <a:prstGeom prst="rect"/>
+        </p:spPr>
+      </p:pic>
+      <p:sp>
+        <p:nvSpPr>
+          <p:cNvPr id="4" name="Date"/>
+          <p:cNvSpPr>
+            <a:spLocks noGrp="1"/>
+          </p:cNvSpPr>
+          <p:nvPr>
+            <p:ph idx="10" sz="half" type="dt"/>
+          </p:nvPr>
+        </p:nvSpPr>
+        <p:spPr/>
+        <p:txBody>
+          <a:bodyPr/>
+          <a:lstStyle/>
+          <a:p>
+            <a:fld id="{5C2C3F0B-2B7F-4782-B315-33E516447C25}" type="datetimeFigureOut">
+              <a:rPr lang="en-US" smtClean="0"/>
+              <a:t>3/21/2019</a:t>
+            </a:fld>
+            <a:endParaRPr lang="en-US"/>
+          </a:p>
+        </p:txBody>
+      </p:sp>
+      <p:sp>
+        <p:nvSpPr>
+          <p:cNvPr id="5" name="Footer"/>
+          <p:cNvSpPr>
+            <a:spLocks noGrp="1"/>
+          </p:cNvSpPr>
+          <p:nvPr>
+            <p:ph idx="11" sz="quarter" type="ftr"/>
+          </p:nvPr>
+        </p:nvSpPr>
+        <p:spPr/>
+        <p:txBody>
+          <a:bodyPr/>
+          <a:lstStyle/>
+          <a:p>
+            <a:endParaRPr lang="en-US"/>
+          </a:p>
+        </p:txBody>
+      </p:sp>
+      <p:sp>
+        <p:nvSpPr>
+          <p:cNvPr id="6" name="Slide Number"/>
+          <p:cNvSpPr>
+            <a:spLocks noGrp="1"/>
+          </p:cNvSpPr>
+          <p:nvPr>
+            <p:ph idx="12" sz="quarter" type="sldNum"/>
+          </p:nvPr>
+        </p:nvSpPr>
+        <p:spPr/>
+        <p:txBody>
+          <a:bodyPr/>
+          <a:lstStyle/>
+          <a:p>
+            <a:fld id="{6FACB95C-998B-4B89-BDB5-3B69D78FCBB4}" type="slidenum">
+              <a:rPr lang="en-US" smtClean="0"/>
+              <a:t>‹#›</a:t>
+            </a:fld>
+            <a:endParaRPr lang="en-US"/>
+          </a:p>
+        </p:txBody>
+      </p:sp>
+    </p:spTree>
+    <p:extLst>
+      <p:ext uri="{BB962C8B-B14F-4D97-AF65-F5344CB8AC3E}">
+        <p14:creationId xmlns:p14="http://schemas.microsoft.com/office/powerpoint/2010/main" val="1534215338"/>
+      </p:ext>
+    </p:extLst>
+  </p:cSld>
+</p:sld>
+</file>
+
+<file path=ppt/slides/slide13.xml><?xml version="1.0" encoding="utf-8"?>
+<p:sld xmlns:a="http://schemas.openxmlformats.org/drawingml/2006/main" xmlns:p="http://schemas.openxmlformats.org/presentationml/2006/main" xmlns:r="http://schemas.openxmlformats.org/officeDocument/2006/relationships">
+  <p:cSld name="">
+    <p:spTree>
+      <p:nvGrpSpPr>
+        <p:cNvPr id="1" name=""/>
+        <p:cNvGrpSpPr/>
+        <p:nvPr/>
+      </p:nvGrpSpPr>
+      <p:grpSpPr>
+        <a:xfrm>
+          <a:off x="0" y="0"/>
+          <a:ext cx="0" cy="0"/>
+          <a:chOff x="0" y="0"/>
+          <a:chExt cx="0" cy="0"/>
+        </a:xfrm>
+      </p:grpSpPr>
+      <p:sp>
+        <p:nvSpPr>
+          <p:cNvPr id="2" name="Title"/>
+          <p:cNvSpPr>
+            <a:spLocks noGrp="1"/>
+          </p:cNvSpPr>
+          <p:nvPr>
+            <p:ph type="title"/>
+          </p:nvPr>
+        </p:nvSpPr>
+        <p:spPr/>
+        <p:txBody>
+          <a:bodyPr/>
+          <a:lstStyle/>
+          <a:p>
+            <a:r>
+              <a:t>West Corridor Due-West Setup</a:t>
+            </a:r>
+          </a:p>
+        </p:txBody>
+      </p:sp>
+      <p:pic>
+        <p:nvPicPr>
+          <p:cNvPr id="3" name="Content"/>
+          <p:cNvPicPr>
+            <a:picLocks noChangeAspect="1" noGrp="1"/>
+          </p:cNvPicPr>
+          <p:nvPr>
+            <p:ph idx="1"/>
+          </p:nvPr>
+        </p:nvPicPr>
+        <p:blipFill>
+          <a:blip r:embed="rId2">
+            <a:extLst>
+              <a:ext uri="{28A0092B-C50C-407E-A947-70E740481C1C}">
+                <a14:useLocalDpi xmlns:a14="http://schemas.microsoft.com/office/drawing/2010/main" val="0"/>
+              </a:ext>
+            </a:extLst>
+          </a:blip>
+          <a:stretch>
+            <a:fillRect/>
+          </a:stretch>
+        </p:blipFill>
+        <p:spPr>
+          <a:xfrm>
+            <a:off x="2319306" y="1825625"/>
+            <a:ext cx="7553386" cy="4351338"/>
+          </a:xfrm>
+          <a:prstGeom prst="rect"/>
+        </p:spPr>
+      </p:pic>
+      <p:sp>
+        <p:nvSpPr>
+          <p:cNvPr id="4" name="Date"/>
+          <p:cNvSpPr>
+            <a:spLocks noGrp="1"/>
+          </p:cNvSpPr>
+          <p:nvPr>
+            <p:ph idx="10" sz="half" type="dt"/>
+          </p:nvPr>
+        </p:nvSpPr>
+        <p:spPr/>
+        <p:txBody>
+          <a:bodyPr/>
+          <a:lstStyle/>
+          <a:p>
+            <a:fld id="{5C2C3F0B-2B7F-4782-B315-33E516447C25}" type="datetimeFigureOut">
+              <a:rPr lang="en-US" smtClean="0"/>
+              <a:t>3/21/2019</a:t>
+            </a:fld>
+            <a:endParaRPr lang="en-US"/>
+          </a:p>
+        </p:txBody>
+      </p:sp>
+      <p:sp>
+        <p:nvSpPr>
+          <p:cNvPr id="5" name="Footer"/>
+          <p:cNvSpPr>
+            <a:spLocks noGrp="1"/>
+          </p:cNvSpPr>
+          <p:nvPr>
+            <p:ph idx="11" sz="quarter" type="ftr"/>
+          </p:nvPr>
+        </p:nvSpPr>
+        <p:spPr/>
+        <p:txBody>
+          <a:bodyPr/>
+          <a:lstStyle/>
+          <a:p>
+            <a:endParaRPr lang="en-US"/>
+          </a:p>
+        </p:txBody>
+      </p:sp>
+      <p:sp>
+        <p:nvSpPr>
+          <p:cNvPr id="6" name="Slide Number"/>
+          <p:cNvSpPr>
+            <a:spLocks noGrp="1"/>
+          </p:cNvSpPr>
+          <p:nvPr>
+            <p:ph idx="12" sz="quarter" type="sldNum"/>
+          </p:nvPr>
+        </p:nvSpPr>
+        <p:spPr/>
+        <p:txBody>
+          <a:bodyPr/>
+          <a:lstStyle/>
+          <a:p>
+            <a:fld id="{6FACB95C-998B-4B89-BDB5-3B69D78FCBB4}" type="slidenum">
+              <a:rPr lang="en-US" smtClean="0"/>
+              <a:t>‹#›</a:t>
+            </a:fld>
+            <a:endParaRPr lang="en-US"/>
+          </a:p>
+        </p:txBody>
+      </p:sp>
+    </p:spTree>
+    <p:extLst>
+      <p:ext uri="{BB962C8B-B14F-4D97-AF65-F5344CB8AC3E}">
+        <p14:creationId xmlns:p14="http://schemas.microsoft.com/office/powerpoint/2010/main" val="1534215338"/>
+      </p:ext>
+    </p:extLst>
+  </p:cSld>
+</p:sld>
+</file>
+
+<file path=ppt/slides/slide14.xml><?xml version="1.0" encoding="utf-8"?>
+<p:sld xmlns:a="http://schemas.openxmlformats.org/drawingml/2006/main" xmlns:p="http://schemas.openxmlformats.org/presentationml/2006/main" xmlns:r="http://schemas.openxmlformats.org/officeDocument/2006/relationships">
+  <p:cSld name="">
+    <p:spTree>
+      <p:nvGrpSpPr>
+        <p:cNvPr id="1" name=""/>
+        <p:cNvGrpSpPr/>
+        <p:nvPr/>
+      </p:nvGrpSpPr>
+      <p:grpSpPr>
+        <a:xfrm>
+          <a:off x="0" y="0"/>
+          <a:ext cx="0" cy="0"/>
+          <a:chOff x="0" y="0"/>
+          <a:chExt cx="0" cy="0"/>
+        </a:xfrm>
+      </p:grpSpPr>
+      <p:sp>
+        <p:nvSpPr>
+          <p:cNvPr id="2" name="Title"/>
+          <p:cNvSpPr>
+            <a:spLocks noGrp="1"/>
+          </p:cNvSpPr>
+          <p:nvPr>
+            <p:ph type="title"/>
+          </p:nvPr>
+        </p:nvSpPr>
+        <p:spPr/>
+        <p:txBody>
+          <a:bodyPr/>
+          <a:lstStyle/>
+          <a:p>
+            <a:r>
+              <a:t>West Corridor Newton Bistatic SNR Coverage</a:t>
+            </a:r>
+          </a:p>
+        </p:txBody>
+      </p:sp>
+      <p:pic>
+        <p:nvPicPr>
+          <p:cNvPr id="3" name="Content"/>
+          <p:cNvPicPr>
+            <a:picLocks noChangeAspect="1" noGrp="1"/>
+          </p:cNvPicPr>
+          <p:nvPr>
+            <p:ph idx="1"/>
+          </p:nvPr>
+        </p:nvPicPr>
+        <p:blipFill>
+          <a:blip r:embed="rId2">
+            <a:extLst>
+              <a:ext uri="{28A0092B-C50C-407E-A947-70E740481C1C}">
+                <a14:useLocalDpi xmlns:a14="http://schemas.microsoft.com/office/drawing/2010/main" val="0"/>
+              </a:ext>
+            </a:extLst>
+          </a:blip>
+          <a:stretch>
+            <a:fillRect/>
+          </a:stretch>
+        </p:blipFill>
+        <p:spPr>
+          <a:xfrm>
+            <a:off x="2164791" y="1825625"/>
+            <a:ext cx="7862417" cy="4351338"/>
+          </a:xfrm>
+          <a:prstGeom prst="rect"/>
+        </p:spPr>
+      </p:pic>
+      <p:sp>
+        <p:nvSpPr>
+          <p:cNvPr id="4" name="Date"/>
+          <p:cNvSpPr>
+            <a:spLocks noGrp="1"/>
+          </p:cNvSpPr>
+          <p:nvPr>
+            <p:ph idx="10" sz="half" type="dt"/>
+          </p:nvPr>
+        </p:nvSpPr>
+        <p:spPr/>
+        <p:txBody>
+          <a:bodyPr/>
+          <a:lstStyle/>
+          <a:p>
+            <a:fld id="{5C2C3F0B-2B7F-4782-B315-33E516447C25}" type="datetimeFigureOut">
+              <a:rPr lang="en-US" smtClean="0"/>
+              <a:t>3/21/2019</a:t>
+            </a:fld>
+            <a:endParaRPr lang="en-US"/>
+          </a:p>
+        </p:txBody>
+      </p:sp>
+      <p:sp>
+        <p:nvSpPr>
+          <p:cNvPr id="5" name="Footer"/>
+          <p:cNvSpPr>
+            <a:spLocks noGrp="1"/>
+          </p:cNvSpPr>
+          <p:nvPr>
+            <p:ph idx="11" sz="quarter" type="ftr"/>
+          </p:nvPr>
+        </p:nvSpPr>
+        <p:spPr/>
+        <p:txBody>
+          <a:bodyPr/>
+          <a:lstStyle/>
+          <a:p>
+            <a:endParaRPr lang="en-US"/>
+          </a:p>
+        </p:txBody>
+      </p:sp>
+      <p:sp>
+        <p:nvSpPr>
+          <p:cNvPr id="6" name="Slide Number"/>
+          <p:cNvSpPr>
+            <a:spLocks noGrp="1"/>
+          </p:cNvSpPr>
+          <p:nvPr>
+            <p:ph idx="12" sz="quarter" type="sldNum"/>
+          </p:nvPr>
+        </p:nvSpPr>
+        <p:spPr/>
+        <p:txBody>
+          <a:bodyPr/>
+          <a:lstStyle/>
+          <a:p>
+            <a:fld id="{6FACB95C-998B-4B89-BDB5-3B69D78FCBB4}" type="slidenum">
+              <a:rPr lang="en-US" smtClean="0"/>
+              <a:t>‹#›</a:t>
+            </a:fld>
+            <a:endParaRPr lang="en-US"/>
+          </a:p>
+        </p:txBody>
+      </p:sp>
+    </p:spTree>
+    <p:extLst>
+      <p:ext uri="{BB962C8B-B14F-4D97-AF65-F5344CB8AC3E}">
+        <p14:creationId xmlns:p14="http://schemas.microsoft.com/office/powerpoint/2010/main" val="1534215338"/>
+      </p:ext>
+    </p:extLst>
+  </p:cSld>
+</p:sld>
+</file>
+
+<file path=ppt/slides/slide15.xml><?xml version="1.0" encoding="utf-8"?>
+<p:sld xmlns:a="http://schemas.openxmlformats.org/drawingml/2006/main" xmlns:p="http://schemas.openxmlformats.org/presentationml/2006/main" xmlns:r="http://schemas.openxmlformats.org/officeDocument/2006/relationships">
+  <p:cSld name="">
+    <p:spTree>
+      <p:nvGrpSpPr>
+        <p:cNvPr id="1" name=""/>
+        <p:cNvGrpSpPr/>
+        <p:nvPr/>
+      </p:nvGrpSpPr>
+      <p:grpSpPr>
+        <a:xfrm>
+          <a:off x="0" y="0"/>
+          <a:ext cx="0" cy="0"/>
+          <a:chOff x="0" y="0"/>
+          <a:chExt cx="0" cy="0"/>
+        </a:xfrm>
+      </p:grpSpPr>
+      <p:sp>
+        <p:nvSpPr>
+          <p:cNvPr id="2" name="Title"/>
+          <p:cNvSpPr>
+            <a:spLocks noGrp="1"/>
+          </p:cNvSpPr>
+          <p:nvPr>
+            <p:ph type="title"/>
+          </p:nvPr>
+        </p:nvSpPr>
+        <p:spPr/>
+        <p:txBody>
+          <a:bodyPr/>
+          <a:lstStyle/>
+          <a:p>
+            <a:r>
+              <a:t>West Corridor Hudson Bistatic SNR Coverage</a:t>
+            </a:r>
+          </a:p>
+        </p:txBody>
+      </p:sp>
+      <p:pic>
+        <p:nvPicPr>
+          <p:cNvPr id="3" name="Content"/>
+          <p:cNvPicPr>
+            <a:picLocks noChangeAspect="1" noGrp="1"/>
+          </p:cNvPicPr>
+          <p:nvPr>
+            <p:ph idx="1"/>
+          </p:nvPr>
+        </p:nvPicPr>
+        <p:blipFill>
+          <a:blip r:embed="rId2">
+            <a:extLst>
+              <a:ext uri="{28A0092B-C50C-407E-A947-70E740481C1C}">
+                <a14:useLocalDpi xmlns:a14="http://schemas.microsoft.com/office/drawing/2010/main" val="0"/>
+              </a:ext>
+            </a:extLst>
+          </a:blip>
+          <a:stretch>
+            <a:fillRect/>
+          </a:stretch>
+        </p:blipFill>
+        <p:spPr>
+          <a:xfrm>
+            <a:off x="2164791" y="1825625"/>
+            <a:ext cx="7862417" cy="4351338"/>
+          </a:xfrm>
+          <a:prstGeom prst="rect"/>
+        </p:spPr>
+      </p:pic>
+      <p:sp>
+        <p:nvSpPr>
+          <p:cNvPr id="4" name="Date"/>
+          <p:cNvSpPr>
+            <a:spLocks noGrp="1"/>
+          </p:cNvSpPr>
+          <p:nvPr>
+            <p:ph idx="10" sz="half" type="dt"/>
+          </p:nvPr>
+        </p:nvSpPr>
+        <p:spPr/>
+        <p:txBody>
+          <a:bodyPr/>
+          <a:lstStyle/>
+          <a:p>
+            <a:fld id="{5C2C3F0B-2B7F-4782-B315-33E516447C25}" type="datetimeFigureOut">
+              <a:rPr lang="en-US" smtClean="0"/>
+              <a:t>3/21/2019</a:t>
+            </a:fld>
+            <a:endParaRPr lang="en-US"/>
+          </a:p>
+        </p:txBody>
+      </p:sp>
+      <p:sp>
+        <p:nvSpPr>
+          <p:cNvPr id="5" name="Footer"/>
+          <p:cNvSpPr>
+            <a:spLocks noGrp="1"/>
+          </p:cNvSpPr>
+          <p:nvPr>
+            <p:ph idx="11" sz="quarter" type="ftr"/>
+          </p:nvPr>
+        </p:nvSpPr>
+        <p:spPr/>
+        <p:txBody>
+          <a:bodyPr/>
+          <a:lstStyle/>
+          <a:p>
+            <a:endParaRPr lang="en-US"/>
+          </a:p>
+        </p:txBody>
+      </p:sp>
+      <p:sp>
+        <p:nvSpPr>
+          <p:cNvPr id="6" name="Slide Number"/>
+          <p:cNvSpPr>
+            <a:spLocks noGrp="1"/>
+          </p:cNvSpPr>
+          <p:nvPr>
+            <p:ph idx="12" sz="quarter" type="sldNum"/>
+          </p:nvPr>
+        </p:nvSpPr>
+        <p:spPr/>
+        <p:txBody>
+          <a:bodyPr/>
+          <a:lstStyle/>
+          <a:p>
+            <a:fld id="{6FACB95C-998B-4B89-BDB5-3B69D78FCBB4}" type="slidenum">
+              <a:rPr lang="en-US" smtClean="0"/>
+              <a:t>‹#›</a:t>
+            </a:fld>
+            <a:endParaRPr lang="en-US"/>
+          </a:p>
+        </p:txBody>
+      </p:sp>
+    </p:spTree>
+    <p:extLst>
+      <p:ext uri="{BB962C8B-B14F-4D97-AF65-F5344CB8AC3E}">
+        <p14:creationId xmlns:p14="http://schemas.microsoft.com/office/powerpoint/2010/main" val="1534215338"/>
+      </p:ext>
+    </p:extLst>
+  </p:cSld>
+</p:sld>
+</file>
+
+<file path=ppt/slides/slide16.xml><?xml version="1.0" encoding="utf-8"?>
+<p:sld xmlns:a="http://schemas.openxmlformats.org/drawingml/2006/main" xmlns:p="http://schemas.openxmlformats.org/presentationml/2006/main" xmlns:r="http://schemas.openxmlformats.org/officeDocument/2006/relationships">
+  <p:cSld name="">
+    <p:spTree>
+      <p:nvGrpSpPr>
+        <p:cNvPr id="1" name=""/>
+        <p:cNvGrpSpPr/>
+        <p:nvPr/>
+      </p:nvGrpSpPr>
+      <p:grpSpPr>
+        <a:xfrm>
+          <a:off x="0" y="0"/>
+          <a:ext cx="0" cy="0"/>
+          <a:chOff x="0" y="0"/>
+          <a:chExt cx="0" cy="0"/>
+        </a:xfrm>
+      </p:grpSpPr>
+      <p:sp>
+        <p:nvSpPr>
+          <p:cNvPr id="2" name="Title"/>
+          <p:cNvSpPr>
+            <a:spLocks noGrp="1"/>
+          </p:cNvSpPr>
+          <p:nvPr>
+            <p:ph type="title"/>
+          </p:nvPr>
+        </p:nvSpPr>
+        <p:spPr/>
+        <p:txBody>
+          <a:bodyPr/>
+          <a:lstStyle/>
+          <a:p>
+            <a:r>
+              <a:t>West Corridor Combined Max-SNR Coverage</a:t>
+            </a:r>
+          </a:p>
+        </p:txBody>
+      </p:sp>
+      <p:pic>
+        <p:nvPicPr>
+          <p:cNvPr id="3" name="Content"/>
+          <p:cNvPicPr>
+            <a:picLocks noChangeAspect="1" noGrp="1"/>
+          </p:cNvPicPr>
+          <p:nvPr>
+            <p:ph idx="1"/>
+          </p:nvPr>
+        </p:nvPicPr>
+        <p:blipFill>
+          <a:blip r:embed="rId2">
+            <a:extLst>
+              <a:ext uri="{28A0092B-C50C-407E-A947-70E740481C1C}">
+                <a14:useLocalDpi xmlns:a14="http://schemas.microsoft.com/office/drawing/2010/main" val="0"/>
+              </a:ext>
+            </a:extLst>
+          </a:blip>
+          <a:stretch>
+            <a:fillRect/>
+          </a:stretch>
+        </p:blipFill>
+        <p:spPr>
+          <a:xfrm>
+            <a:off x="2359851" y="1825625"/>
+            <a:ext cx="7472297" cy="4351338"/>
+          </a:xfrm>
+          <a:prstGeom prst="rect"/>
+        </p:spPr>
+      </p:pic>
+      <p:sp>
+        <p:nvSpPr>
+          <p:cNvPr id="4" name="Date"/>
+          <p:cNvSpPr>
+            <a:spLocks noGrp="1"/>
+          </p:cNvSpPr>
+          <p:nvPr>
+            <p:ph idx="10" sz="half" type="dt"/>
+          </p:nvPr>
+        </p:nvSpPr>
+        <p:spPr/>
+        <p:txBody>
+          <a:bodyPr/>
+          <a:lstStyle/>
+          <a:p>
+            <a:fld id="{5C2C3F0B-2B7F-4782-B315-33E516447C25}" type="datetimeFigureOut">
+              <a:rPr lang="en-US" smtClean="0"/>
+              <a:t>3/21/2019</a:t>
+            </a:fld>
+            <a:endParaRPr lang="en-US"/>
+          </a:p>
+        </p:txBody>
+      </p:sp>
+      <p:sp>
+        <p:nvSpPr>
+          <p:cNvPr id="5" name="Footer"/>
+          <p:cNvSpPr>
+            <a:spLocks noGrp="1"/>
+          </p:cNvSpPr>
+          <p:nvPr>
+            <p:ph idx="11" sz="quarter" type="ftr"/>
+          </p:nvPr>
+        </p:nvSpPr>
+        <p:spPr/>
+        <p:txBody>
+          <a:bodyPr/>
+          <a:lstStyle/>
+          <a:p>
+            <a:endParaRPr lang="en-US"/>
+          </a:p>
+        </p:txBody>
+      </p:sp>
+      <p:sp>
+        <p:nvSpPr>
+          <p:cNvPr id="6" name="Slide Number"/>
+          <p:cNvSpPr>
+            <a:spLocks noGrp="1"/>
+          </p:cNvSpPr>
+          <p:nvPr>
+            <p:ph idx="12" sz="quarter" type="sldNum"/>
+          </p:nvPr>
+        </p:nvSpPr>
+        <p:spPr/>
+        <p:txBody>
+          <a:bodyPr/>
+          <a:lstStyle/>
+          <a:p>
+            <a:fld id="{6FACB95C-998B-4B89-BDB5-3B69D78FCBB4}" type="slidenum">
+              <a:rPr lang="en-US" smtClean="0"/>
+              <a:t>‹#›</a:t>
+            </a:fld>
+            <a:endParaRPr lang="en-US"/>
+          </a:p>
+        </p:txBody>
+      </p:sp>
+    </p:spTree>
+    <p:extLst>
+      <p:ext uri="{BB962C8B-B14F-4D97-AF65-F5344CB8AC3E}">
+        <p14:creationId xmlns:p14="http://schemas.microsoft.com/office/powerpoint/2010/main" val="1534215338"/>
+      </p:ext>
+    </p:extLst>
+  </p:cSld>
+</p:sld>
+</file>
+
+<file path=ppt/slides/slide17.xml><?xml version="1.0" encoding="utf-8"?>
+<p:sld xmlns:a="http://schemas.openxmlformats.org/drawingml/2006/main" xmlns:p="http://schemas.openxmlformats.org/presentationml/2006/main" xmlns:r="http://schemas.openxmlformats.org/officeDocument/2006/relationships">
+  <p:cSld name="">
+    <p:spTree>
+      <p:nvGrpSpPr>
+        <p:cNvPr id="1" name=""/>
+        <p:cNvGrpSpPr/>
+        <p:nvPr/>
+      </p:nvGrpSpPr>
+      <p:grpSpPr>
+        <a:xfrm>
+          <a:off x="0" y="0"/>
+          <a:ext cx="0" cy="0"/>
+          <a:chOff x="0" y="0"/>
+          <a:chExt cx="0" cy="0"/>
+        </a:xfrm>
+      </p:grpSpPr>
+      <p:sp>
+        <p:nvSpPr>
+          <p:cNvPr id="2" name="Title"/>
+          <p:cNvSpPr>
+            <a:spLocks noGrp="1"/>
+          </p:cNvSpPr>
+          <p:nvPr>
+            <p:ph type="title"/>
+          </p:nvPr>
+        </p:nvSpPr>
+        <p:spPr/>
+        <p:txBody>
+          <a:bodyPr/>
+          <a:lstStyle/>
+          <a:p>
+            <a:r>
+              <a:t>West Corridor Regional SNR View</a:t>
+            </a:r>
+          </a:p>
+        </p:txBody>
+      </p:sp>
+      <p:pic>
+        <p:nvPicPr>
+          <p:cNvPr id="3" name="Content"/>
+          <p:cNvPicPr>
+            <a:picLocks noChangeAspect="1" noGrp="1"/>
+          </p:cNvPicPr>
+          <p:nvPr>
+            <p:ph idx="1"/>
+          </p:nvPr>
+        </p:nvPicPr>
+        <p:blipFill>
+          <a:blip r:embed="rId2">
+            <a:extLst>
+              <a:ext uri="{28A0092B-C50C-407E-A947-70E740481C1C}">
+                <a14:useLocalDpi xmlns:a14="http://schemas.microsoft.com/office/drawing/2010/main" val="0"/>
+              </a:ext>
+            </a:extLst>
+          </a:blip>
+          <a:stretch>
+            <a:fillRect/>
+          </a:stretch>
+        </p:blipFill>
+        <p:spPr>
+          <a:xfrm>
+            <a:off x="2166866" y="1825625"/>
+            <a:ext cx="7858267" cy="4351338"/>
+          </a:xfrm>
+          <a:prstGeom prst="rect"/>
+        </p:spPr>
+      </p:pic>
+      <p:sp>
+        <p:nvSpPr>
+          <p:cNvPr id="4" name="Date"/>
+          <p:cNvSpPr>
+            <a:spLocks noGrp="1"/>
+          </p:cNvSpPr>
+          <p:nvPr>
+            <p:ph idx="10" sz="half" type="dt"/>
+          </p:nvPr>
+        </p:nvSpPr>
+        <p:spPr/>
+        <p:txBody>
+          <a:bodyPr/>
+          <a:lstStyle/>
+          <a:p>
+            <a:fld id="{5C2C3F0B-2B7F-4782-B315-33E516447C25}" type="datetimeFigureOut">
+              <a:rPr lang="en-US" smtClean="0"/>
+              <a:t>3/21/2019</a:t>
+            </a:fld>
+            <a:endParaRPr lang="en-US"/>
+          </a:p>
+        </p:txBody>
+      </p:sp>
+      <p:sp>
+        <p:nvSpPr>
+          <p:cNvPr id="5" name="Footer"/>
+          <p:cNvSpPr>
+            <a:spLocks noGrp="1"/>
+          </p:cNvSpPr>
+          <p:nvPr>
+            <p:ph idx="11" sz="quarter" type="ftr"/>
+          </p:nvPr>
+        </p:nvSpPr>
+        <p:spPr/>
+        <p:txBody>
+          <a:bodyPr/>
+          <a:lstStyle/>
+          <a:p>
+            <a:endParaRPr lang="en-US"/>
+          </a:p>
+        </p:txBody>
+      </p:sp>
+      <p:sp>
+        <p:nvSpPr>
+          <p:cNvPr id="6" name="Slide Number"/>
+          <p:cNvSpPr>
+            <a:spLocks noGrp="1"/>
+          </p:cNvSpPr>
+          <p:nvPr>
+            <p:ph idx="12" sz="quarter" type="sldNum"/>
+          </p:nvPr>
+        </p:nvSpPr>
+        <p:spPr/>
+        <p:txBody>
+          <a:bodyPr/>
+          <a:lstStyle/>
+          <a:p>
+            <a:fld id="{6FACB95C-998B-4B89-BDB5-3B69D78FCBB4}" type="slidenum">
+              <a:rPr lang="en-US" smtClean="0"/>
+              <a:t>‹#›</a:t>
+            </a:fld>
+            <a:endParaRPr lang="en-US"/>
+          </a:p>
+        </p:txBody>
+      </p:sp>
+    </p:spTree>
+    <p:extLst>
+      <p:ext uri="{BB962C8B-B14F-4D97-AF65-F5344CB8AC3E}">
+        <p14:creationId xmlns:p14="http://schemas.microsoft.com/office/powerpoint/2010/main" val="1534215338"/>
+      </p:ext>
+    </p:extLst>
+  </p:cSld>
+</p:sld>
+</file>
+
+<file path=ppt/slides/slide18.xml><?xml version="1.0" encoding="utf-8"?>
+<p:sld xmlns:a="http://schemas.openxmlformats.org/drawingml/2006/main" xmlns:p="http://schemas.openxmlformats.org/presentationml/2006/main" xmlns:r="http://schemas.openxmlformats.org/officeDocument/2006/relationships">
+  <p:cSld name="">
+    <p:spTree>
+      <p:nvGrpSpPr>
+        <p:cNvPr id="1" name=""/>
+        <p:cNvGrpSpPr/>
+        <p:nvPr/>
+      </p:nvGrpSpPr>
+      <p:grpSpPr>
+        <a:xfrm>
+          <a:off x="0" y="0"/>
+          <a:ext cx="0" cy="0"/>
+          <a:chOff x="0" y="0"/>
+          <a:chExt cx="0" cy="0"/>
+        </a:xfrm>
+      </p:grpSpPr>
+      <p:sp>
+        <p:nvSpPr>
+          <p:cNvPr id="2" name="Title"/>
+          <p:cNvSpPr>
+            <a:spLocks noGrp="1"/>
+          </p:cNvSpPr>
+          <p:nvPr>
+            <p:ph type="title"/>
+          </p:nvPr>
+        </p:nvSpPr>
+        <p:spPr/>
+        <p:txBody>
+          <a:bodyPr/>
+          <a:lstStyle/>
+          <a:p>
+            <a:r>
+              <a:t>West Corridor Detectability Summary</a:t>
+            </a:r>
+          </a:p>
+        </p:txBody>
+      </p:sp>
+      <p:pic>
+        <p:nvPicPr>
+          <p:cNvPr id="3" name="Content"/>
+          <p:cNvPicPr>
+            <a:picLocks noChangeAspect="1" noGrp="1"/>
+          </p:cNvPicPr>
+          <p:nvPr>
+            <p:ph idx="1"/>
+          </p:nvPr>
+        </p:nvPicPr>
+        <p:blipFill>
+          <a:blip r:embed="rId2">
+            <a:extLst>
+              <a:ext uri="{28A0092B-C50C-407E-A947-70E740481C1C}">
+                <a14:useLocalDpi xmlns:a14="http://schemas.microsoft.com/office/drawing/2010/main" val="0"/>
+              </a:ext>
+            </a:extLst>
+          </a:blip>
+          <a:stretch>
+            <a:fillRect/>
+          </a:stretch>
+        </p:blipFill>
+        <p:spPr>
+          <a:xfrm>
+            <a:off x="2377224" y="1825625"/>
+            <a:ext cx="7437550" cy="4351338"/>
+          </a:xfrm>
+          <a:prstGeom prst="rect"/>
+        </p:spPr>
+      </p:pic>
+      <p:sp>
+        <p:nvSpPr>
+          <p:cNvPr id="4" name="Date"/>
+          <p:cNvSpPr>
+            <a:spLocks noGrp="1"/>
+          </p:cNvSpPr>
+          <p:nvPr>
+            <p:ph idx="10" sz="half" type="dt"/>
+          </p:nvPr>
+        </p:nvSpPr>
+        <p:spPr/>
+        <p:txBody>
+          <a:bodyPr/>
+          <a:lstStyle/>
+          <a:p>
+            <a:fld id="{5C2C3F0B-2B7F-4782-B315-33E516447C25}" type="datetimeFigureOut">
+              <a:rPr lang="en-US" smtClean="0"/>
+              <a:t>3/21/2019</a:t>
+            </a:fld>
+            <a:endParaRPr lang="en-US"/>
+          </a:p>
+        </p:txBody>
+      </p:sp>
+      <p:sp>
+        <p:nvSpPr>
+          <p:cNvPr id="5" name="Footer"/>
+          <p:cNvSpPr>
+            <a:spLocks noGrp="1"/>
+          </p:cNvSpPr>
+          <p:nvPr>
+            <p:ph idx="11" sz="quarter" type="ftr"/>
+          </p:nvPr>
+        </p:nvSpPr>
+        <p:spPr/>
+        <p:txBody>
+          <a:bodyPr/>
+          <a:lstStyle/>
+          <a:p>
+            <a:endParaRPr lang="en-US"/>
+          </a:p>
+        </p:txBody>
+      </p:sp>
+      <p:sp>
+        <p:nvSpPr>
+          <p:cNvPr id="6" name="Slide Number"/>
+          <p:cNvSpPr>
+            <a:spLocks noGrp="1"/>
+          </p:cNvSpPr>
+          <p:nvPr>
+            <p:ph idx="12" sz="quarter" type="sldNum"/>
+          </p:nvPr>
+        </p:nvSpPr>
+        <p:spPr/>
+        <p:txBody>
+          <a:bodyPr/>
+          <a:lstStyle/>
+          <a:p>
+            <a:fld id="{6FACB95C-998B-4B89-BDB5-3B69D78FCBB4}" type="slidenum">
+              <a:rPr lang="en-US" smtClean="0"/>
+              <a:t>‹#›</a:t>
+            </a:fld>
+            <a:endParaRPr lang="en-US"/>
+          </a:p>
+        </p:txBody>
+      </p:sp>
+    </p:spTree>
+    <p:extLst>
+      <p:ext uri="{BB962C8B-B14F-4D97-AF65-F5344CB8AC3E}">
+        <p14:creationId xmlns:p14="http://schemas.microsoft.com/office/powerpoint/2010/main" val="1534215338"/>
+      </p:ext>
+    </p:extLst>
+  </p:cSld>
+</p:sld>
+</file>
+
+<file path=ppt/slides/slide19.xml><?xml version="1.0" encoding="utf-8"?>
+<p:sld xmlns:a="http://schemas.openxmlformats.org/drawingml/2006/main" xmlns:p="http://schemas.openxmlformats.org/presentationml/2006/main" xmlns:r="http://schemas.openxmlformats.org/officeDocument/2006/relationships">
+  <p:cSld name="">
+    <p:spTree>
+      <p:nvGrpSpPr>
+        <p:cNvPr id="1" name=""/>
+        <p:cNvGrpSpPr/>
+        <p:nvPr/>
+      </p:nvGrpSpPr>
+      <p:grpSpPr>
+        <a:xfrm>
+          <a:off x="0" y="0"/>
+          <a:ext cx="0" cy="0"/>
+          <a:chOff x="0" y="0"/>
+          <a:chExt cx="0" cy="0"/>
+        </a:xfrm>
+      </p:grpSpPr>
+      <p:sp>
+        <p:nvSpPr>
+          <p:cNvPr id="2" name="Title"/>
+          <p:cNvSpPr>
+            <a:spLocks noGrp="1"/>
+          </p:cNvSpPr>
+          <p:nvPr>
+            <p:ph type="title"/>
+          </p:nvPr>
+        </p:nvSpPr>
+        <p:spPr/>
+        <p:txBody>
+          <a:bodyPr/>
+          <a:lstStyle/>
+          <a:p>
+            <a:r>
+              <a:t>Risks and Scope Boundaries</a:t>
+            </a:r>
+          </a:p>
+        </p:txBody>
+      </p:sp>
+      <p:sp>
+        <p:nvSpPr>
+          <p:cNvPr id="3" name="Content"/>
+          <p:cNvSpPr>
+            <a:spLocks noGrp="1"/>
+          </p:cNvSpPr>
+          <p:nvPr>
+            <p:ph idx="1"/>
+          </p:nvPr>
+        </p:nvSpPr>
+        <p:spPr/>
+        <p:txBody>
+          <a:bodyPr/>
+          <a:lstStyle/>
+          <a:p>
+            <a:r>
+              <a:t>Direct-path power remains the dominant RF risk and still implies a heavily attenuated reference branch.
+Target-path strength is deterministic model output, not field-validated aircraft data.
+Adjacent-channel environment, assembled-chain headroom, and interference tolerance still need bench or field checks.
+This deck supports pre-hardware plausibility only; it does not claim calibration, DSI cancellation, clutter rejection, or measured detection performance.</a:t>
+            </a:r>
+          </a:p>
+        </p:txBody>
+      </p:sp>
+      <p:sp>
+        <p:nvSpPr>
+          <p:cNvPr id="4" name="Date"/>
+          <p:cNvSpPr>
+            <a:spLocks noGrp="1"/>
+          </p:cNvSpPr>
+          <p:nvPr>
+            <p:ph idx="10" sz="half" type="dt"/>
+          </p:nvPr>
+        </p:nvSpPr>
+        <p:spPr/>
+        <p:txBody>
+          <a:bodyPr/>
+          <a:lstStyle/>
+          <a:p>
+            <a:fld id="{5C2C3F0B-2B7F-4782-B315-33E516447C25}" type="datetimeFigureOut">
+              <a:rPr lang="en-US" smtClean="0"/>
+              <a:t>3/21/2019</a:t>
+            </a:fld>
+            <a:endParaRPr lang="en-US"/>
+          </a:p>
+        </p:txBody>
+      </p:sp>
+      <p:sp>
+        <p:nvSpPr>
+          <p:cNvPr id="5" name="Footer"/>
+          <p:cNvSpPr>
+            <a:spLocks noGrp="1"/>
+          </p:cNvSpPr>
+          <p:nvPr>
+            <p:ph idx="11" sz="quarter" type="ftr"/>
+          </p:nvPr>
+        </p:nvSpPr>
+        <p:spPr/>
+        <p:txBody>
+          <a:bodyPr/>
+          <a:lstStyle/>
+          <a:p>
+            <a:endParaRPr lang="en-US"/>
+          </a:p>
+        </p:txBody>
+      </p:sp>
+      <p:sp>
+        <p:nvSpPr>
+          <p:cNvPr id="6" name="Slide Number"/>
+          <p:cNvSpPr>
+            <a:spLocks noGrp="1"/>
+          </p:cNvSpPr>
+          <p:nvPr>
+            <p:ph idx="12" sz="quarter" type="sldNum"/>
+          </p:nvPr>
+        </p:nvSpPr>
+        <p:spPr/>
+        <p:txBody>
+          <a:bodyPr/>
+          <a:lstStyle/>
+          <a:p>
+            <a:fld id="{6FACB95C-998B-4B89-BDB5-3B69D78FCBB4}" type="slidenum">
+              <a:rPr lang="en-US" smtClean="0"/>
+              <a:t>‹#›</a:t>
+            </a:fld>
+            <a:endParaRPr lang="en-US"/>
+          </a:p>
+        </p:txBody>
+      </p:sp>
+    </p:spTree>
+    <p:extLst>
+      <p:ext uri="{BB962C8B-B14F-4D97-AF65-F5344CB8AC3E}">
+        <p14:creationId xmlns:p14="http://schemas.microsoft.com/office/powerpoint/2010/main" val="1534215338"/>
       </p:ext>
     </p:extLst>
   </p:cSld>
@@ -3389,7 +4824,7 @@
           <a:lstStyle/>
           <a:p>
             <a:r>
-              <a:t>Operational Context and Assumptions</a:t>
+              <a:t>Assumptions and Geometry Context</a:t>
             </a:r>
           </a:p>
         </p:txBody>
@@ -3418,8 +4853,8 @@
         </p:blipFill>
         <p:spPr>
           <a:xfrm>
-            <a:off x="838200" y="3062120"/>
-            <a:ext cx="10515600" cy="1878347"/>
+            <a:off x="2139875" y="1825625"/>
+            <a:ext cx="7912249" cy="4351338"/>
           </a:xfrm>
           <a:prstGeom prst="rect"/>
         </p:spPr>
@@ -3532,7 +4967,7 @@
           <a:lstStyle/>
           <a:p>
             <a:r>
-              <a:t>Illuminator Viability</a:t>
+              <a:t>Direct-Path Source Viability</a:t>
             </a:r>
           </a:p>
         </p:txBody>
@@ -3561,8 +4996,8 @@
         </p:blipFill>
         <p:spPr>
           <a:xfrm>
-            <a:off x="1848940" y="1825625"/>
-            <a:ext cx="8494119" cy="4351338"/>
+            <a:off x="2232706" y="1825625"/>
+            <a:ext cx="7726586" cy="4351338"/>
           </a:xfrm>
           <a:prstGeom prst="rect"/>
         </p:spPr>
@@ -3675,7 +5110,7 @@
           <a:lstStyle/>
           <a:p>
             <a:r>
-              <a:t>RF Front-End Capturability</a:t>
+              <a:t>RF Chain Gain and Noise Figure</a:t>
             </a:r>
           </a:p>
         </p:txBody>
@@ -3704,8 +5139,8 @@
         </p:blipFill>
         <p:spPr>
           <a:xfrm>
-            <a:off x="2943004" y="1825625"/>
-            <a:ext cx="6305991" cy="4351338"/>
+            <a:off x="2350944" y="1825625"/>
+            <a:ext cx="7490111" cy="4351338"/>
           </a:xfrm>
           <a:prstGeom prst="rect"/>
         </p:spPr>
@@ -3818,7 +5253,7 @@
           <a:lstStyle/>
           <a:p>
             <a:r>
-              <a:t>Bistatic Detectability Plausibility</a:t>
+              <a:t>RF Levels, Headroom, and Reference Attenuation</a:t>
             </a:r>
           </a:p>
         </p:txBody>
@@ -3847,8 +5282,8 @@
         </p:blipFill>
         <p:spPr>
           <a:xfrm>
-            <a:off x="2013963" y="1825625"/>
-            <a:ext cx="8164073" cy="4351338"/>
+            <a:off x="2404075" y="1825625"/>
+            <a:ext cx="7383849" cy="4351338"/>
           </a:xfrm>
           <a:prstGeom prst="rect"/>
         </p:spPr>
@@ -3961,41 +5396,36 @@
           <a:lstStyle/>
           <a:p>
             <a:r>
-              <a:t>Link Budget Triage Summary</a:t>
-            </a:r>
-          </a:p>
-        </p:txBody>
-      </p:sp>
-      <p:pic>
-        <p:nvPicPr>
+              <a:t>RF Budget Analyzer Component View</a:t>
+            </a:r>
+          </a:p>
+        </p:txBody>
+      </p:sp>
+      <p:sp>
+        <p:nvSpPr>
           <p:cNvPr id="3" name="Content"/>
-          <p:cNvPicPr>
-            <a:picLocks noChangeAspect="1" noGrp="1"/>
-          </p:cNvPicPr>
+          <p:cNvSpPr>
+            <a:spLocks noGrp="1"/>
+          </p:cNvSpPr>
           <p:nvPr>
             <p:ph idx="1"/>
           </p:nvPr>
-        </p:nvPicPr>
-        <p:blipFill>
-          <a:blip r:embed="rId2">
-            <a:extLst>
-              <a:ext uri="{28A0092B-C50C-407E-A947-70E740481C1C}">
-                <a14:useLocalDpi xmlns:a14="http://schemas.microsoft.com/office/drawing/2010/main" val="0"/>
-              </a:ext>
-            </a:extLst>
-          </a:blip>
-          <a:stretch>
-            <a:fillRect/>
-          </a:stretch>
-        </p:blipFill>
-        <p:spPr>
-          <a:xfrm>
-            <a:off x="838200" y="3121508"/>
-            <a:ext cx="10515600" cy="1759571"/>
-          </a:xfrm>
-          <a:prstGeom prst="rect"/>
-        </p:spPr>
-      </p:pic>
+        </p:nvSpPr>
+        <p:spPr/>
+        <p:txBody>
+          <a:bodyPr/>
+          <a:lstStyle/>
+          <a:p>
+            <a:r>
+              <a:t>Manual RF Budget Analyzer screenshot pending.
+Expected artifact path: C:\Users\pwilliam\agenticProjects\flightTest-systemprechecks\SystemPrechecks\Artifacts\Figures\SystemPrecheck_RFBudgetAnalyzer_Newton.png
+Run helperOpenSystemPrecheckRfAnalyzer("Newton") in desktop MATLAB.
+Capture the native show(budget) component view and save it to the fixed path.
+Regenerate the deck after the screenshot is in place.</a:t>
+            </a:r>
+          </a:p>
+        </p:txBody>
+      </p:sp>
       <p:sp>
         <p:nvSpPr>
           <p:cNvPr id="4" name="Date"/>
@@ -4104,7 +5534,7 @@
           <a:lstStyle/>
           <a:p>
             <a:r>
-              <a:t>RF Risk Summary</a:t>
+              <a:t>Recovered-ROI Baseline Target-Grid Setup</a:t>
             </a:r>
           </a:p>
         </p:txBody>
@@ -4133,8 +5563,8 @@
         </p:blipFill>
         <p:spPr>
           <a:xfrm>
-            <a:off x="838200" y="2633182"/>
-            <a:ext cx="10515600" cy="2736222"/>
+            <a:off x="2122969" y="1825625"/>
+            <a:ext cx="7946060" cy="4351338"/>
           </a:xfrm>
           <a:prstGeom prst="rect"/>
         </p:spPr>
@@ -4247,7 +5677,7 @@
           <a:lstStyle/>
           <a:p>
             <a:r>
-              <a:t>Boundaries and Excluded Effects</a:t>
+              <a:t>Recovered-ROI Baseline Newton Bistatic SNR Coverage</a:t>
             </a:r>
           </a:p>
         </p:txBody>
@@ -4276,8 +5706,151 @@
         </p:blipFill>
         <p:spPr>
           <a:xfrm>
-            <a:off x="838200" y="3182386"/>
-            <a:ext cx="10515600" cy="1637815"/>
+            <a:off x="2164791" y="1825625"/>
+            <a:ext cx="7862417" cy="4351338"/>
+          </a:xfrm>
+          <a:prstGeom prst="rect"/>
+        </p:spPr>
+      </p:pic>
+      <p:sp>
+        <p:nvSpPr>
+          <p:cNvPr id="4" name="Date"/>
+          <p:cNvSpPr>
+            <a:spLocks noGrp="1"/>
+          </p:cNvSpPr>
+          <p:nvPr>
+            <p:ph idx="10" sz="half" type="dt"/>
+          </p:nvPr>
+        </p:nvSpPr>
+        <p:spPr/>
+        <p:txBody>
+          <a:bodyPr/>
+          <a:lstStyle/>
+          <a:p>
+            <a:fld id="{5C2C3F0B-2B7F-4782-B315-33E516447C25}" type="datetimeFigureOut">
+              <a:rPr lang="en-US" smtClean="0"/>
+              <a:t>3/21/2019</a:t>
+            </a:fld>
+            <a:endParaRPr lang="en-US"/>
+          </a:p>
+        </p:txBody>
+      </p:sp>
+      <p:sp>
+        <p:nvSpPr>
+          <p:cNvPr id="5" name="Footer"/>
+          <p:cNvSpPr>
+            <a:spLocks noGrp="1"/>
+          </p:cNvSpPr>
+          <p:nvPr>
+            <p:ph idx="11" sz="quarter" type="ftr"/>
+          </p:nvPr>
+        </p:nvSpPr>
+        <p:spPr/>
+        <p:txBody>
+          <a:bodyPr/>
+          <a:lstStyle/>
+          <a:p>
+            <a:endParaRPr lang="en-US"/>
+          </a:p>
+        </p:txBody>
+      </p:sp>
+      <p:sp>
+        <p:nvSpPr>
+          <p:cNvPr id="6" name="Slide Number"/>
+          <p:cNvSpPr>
+            <a:spLocks noGrp="1"/>
+          </p:cNvSpPr>
+          <p:nvPr>
+            <p:ph idx="12" sz="quarter" type="sldNum"/>
+          </p:nvPr>
+        </p:nvSpPr>
+        <p:spPr/>
+        <p:txBody>
+          <a:bodyPr/>
+          <a:lstStyle/>
+          <a:p>
+            <a:fld id="{6FACB95C-998B-4B89-BDB5-3B69D78FCBB4}" type="slidenum">
+              <a:rPr lang="en-US" smtClean="0"/>
+              <a:t>‹#›</a:t>
+            </a:fld>
+            <a:endParaRPr lang="en-US"/>
+          </a:p>
+        </p:txBody>
+      </p:sp>
+    </p:spTree>
+    <p:extLst>
+      <p:ext uri="{BB962C8B-B14F-4D97-AF65-F5344CB8AC3E}">
+        <p14:creationId xmlns:p14="http://schemas.microsoft.com/office/powerpoint/2010/main" val="1534215338"/>
+      </p:ext>
+    </p:extLst>
+  </p:cSld>
+</p:sld>
+</file>
+
+<file path=ppt/slides/slide9.xml><?xml version="1.0" encoding="utf-8"?>
+<p:sld xmlns:a="http://schemas.openxmlformats.org/drawingml/2006/main" xmlns:p="http://schemas.openxmlformats.org/presentationml/2006/main" xmlns:r="http://schemas.openxmlformats.org/officeDocument/2006/relationships">
+  <p:cSld name="">
+    <p:spTree>
+      <p:nvGrpSpPr>
+        <p:cNvPr id="1" name=""/>
+        <p:cNvGrpSpPr/>
+        <p:nvPr/>
+      </p:nvGrpSpPr>
+      <p:grpSpPr>
+        <a:xfrm>
+          <a:off x="0" y="0"/>
+          <a:ext cx="0" cy="0"/>
+          <a:chOff x="0" y="0"/>
+          <a:chExt cx="0" cy="0"/>
+        </a:xfrm>
+      </p:grpSpPr>
+      <p:sp>
+        <p:nvSpPr>
+          <p:cNvPr id="2" name="Title"/>
+          <p:cNvSpPr>
+            <a:spLocks noGrp="1"/>
+          </p:cNvSpPr>
+          <p:nvPr>
+            <p:ph type="title"/>
+          </p:nvPr>
+        </p:nvSpPr>
+        <p:spPr/>
+        <p:txBody>
+          <a:bodyPr/>
+          <a:lstStyle/>
+          <a:p>
+            <a:r>
+              <a:t>Recovered-ROI Baseline Hudson Bistatic SNR Coverage</a:t>
+            </a:r>
+          </a:p>
+        </p:txBody>
+      </p:sp>
+      <p:pic>
+        <p:nvPicPr>
+          <p:cNvPr id="3" name="Content"/>
+          <p:cNvPicPr>
+            <a:picLocks noChangeAspect="1" noGrp="1"/>
+          </p:cNvPicPr>
+          <p:nvPr>
+            <p:ph idx="1"/>
+          </p:nvPr>
+        </p:nvPicPr>
+        <p:blipFill>
+          <a:blip r:embed="rId2">
+            <a:extLst>
+              <a:ext uri="{28A0092B-C50C-407E-A947-70E740481C1C}">
+                <a14:useLocalDpi xmlns:a14="http://schemas.microsoft.com/office/drawing/2010/main" val="0"/>
+              </a:ext>
+            </a:extLst>
+          </a:blip>
+          <a:stretch>
+            <a:fillRect/>
+          </a:stretch>
+        </p:blipFill>
+        <p:spPr>
+          <a:xfrm>
+            <a:off x="2164791" y="1825625"/>
+            <a:ext cx="7862417" cy="4351338"/>
           </a:xfrm>
           <a:prstGeom prst="rect"/>
         </p:spPr>

</xml_diff>